<commit_message>
minor update to pitch deck
</commit_message>
<xml_diff>
--- a/AltHealth_VenturePartner_Pitch.pptx
+++ b/AltHealth_VenturePartner_Pitch.pptx
@@ -5,20 +5,20 @@
     <p:sldMasterId id="2147483648" r:id="rId1"/>
   </p:sldMasterIdLst>
   <p:sldIdLst>
-    <p:sldId id="256" r:id="rId7"/>
-    <p:sldId id="257" r:id="rId8"/>
-    <p:sldId id="258" r:id="rId9"/>
-    <p:sldId id="259" r:id="rId10"/>
-    <p:sldId id="260" r:id="rId11"/>
-    <p:sldId id="261" r:id="rId12"/>
-    <p:sldId id="262" r:id="rId13"/>
-    <p:sldId id="263" r:id="rId14"/>
-    <p:sldId id="264" r:id="rId15"/>
-    <p:sldId id="265" r:id="rId16"/>
-    <p:sldId id="266" r:id="rId17"/>
-    <p:sldId id="267" r:id="rId18"/>
+    <p:sldId id="256" r:id="rId2"/>
+    <p:sldId id="257" r:id="rId3"/>
+    <p:sldId id="258" r:id="rId4"/>
+    <p:sldId id="259" r:id="rId5"/>
+    <p:sldId id="260" r:id="rId6"/>
+    <p:sldId id="261" r:id="rId7"/>
+    <p:sldId id="262" r:id="rId8"/>
+    <p:sldId id="263" r:id="rId9"/>
+    <p:sldId id="264" r:id="rId10"/>
+    <p:sldId id="265" r:id="rId11"/>
+    <p:sldId id="266" r:id="rId12"/>
+    <p:sldId id="267" r:id="rId13"/>
   </p:sldIdLst>
-  <p:sldSz cx="12188952" cy="6858000" type="screen4x3"/>
+  <p:sldSz cx="12188825" cy="6858000"/>
   <p:notesSz cx="6858000" cy="9144000"/>
   <p:defaultTextStyle>
     <a:defPPr>
@@ -115,6 +115,22 @@
       </a:defRPr>
     </a:lvl9pPr>
   </p:defaultTextStyle>
+  <p:extLst>
+    <p:ext uri="{EFAFB233-063F-42B5-8137-9DF3F51BA10A}">
+      <p15:sldGuideLst xmlns:p15="http://schemas.microsoft.com/office/powerpoint/2012/main">
+        <p15:guide id="1" orient="horz" pos="2160">
+          <p15:clr>
+            <a:srgbClr val="A4A3A4"/>
+          </p15:clr>
+        </p15:guide>
+        <p15:guide id="2" pos="2880">
+          <p15:clr>
+            <a:srgbClr val="A4A3A4"/>
+          </p15:clr>
+        </p15:guide>
+      </p15:sldGuideLst>
+    </p:ext>
+  </p:extLst>
 </p:presentation>
 </file>
 
@@ -156,10 +172,9 @@
           <a:lstStyle/>
           <a:p>
             <a:r>
-              <a:rPr lang="en-US" smtClean="0"/>
+              <a:rPr lang="en-US"/>
               <a:t>Click to edit Master title style</a:t>
             </a:r>
-            <a:endParaRPr lang="en-US"/>
           </a:p>
         </p:txBody>
       </p:sp>
@@ -275,10 +290,9 @@
           </a:lstStyle>
           <a:p>
             <a:r>
-              <a:rPr lang="en-US" smtClean="0"/>
+              <a:rPr lang="en-US"/>
               <a:t>Click to edit Master subtitle style</a:t>
             </a:r>
-            <a:endParaRPr lang="en-US"/>
           </a:p>
         </p:txBody>
       </p:sp>
@@ -299,7 +313,7 @@
           <a:p>
             <a:fld id="{5BCAD085-E8A6-8845-BD4E-CB4CCA059FC4}" type="datetimeFigureOut">
               <a:rPr lang="en-US" smtClean="0"/>
-              <a:t>1/27/13</a:t>
+              <a:t>5/10/26</a:t>
             </a:fld>
             <a:endParaRPr lang="en-US"/>
           </a:p>
@@ -393,10 +407,9 @@
           <a:lstStyle/>
           <a:p>
             <a:r>
-              <a:rPr lang="en-US" smtClean="0"/>
+              <a:rPr lang="en-US"/>
               <a:t>Click to edit Master title style</a:t>
             </a:r>
-            <a:endParaRPr lang="en-US"/>
           </a:p>
         </p:txBody>
       </p:sp>
@@ -417,38 +430,37 @@
           <a:p>
             <a:pPr lvl="0"/>
             <a:r>
-              <a:rPr lang="en-US" smtClean="0"/>
+              <a:rPr lang="en-US"/>
               <a:t>Click to edit Master text styles</a:t>
             </a:r>
           </a:p>
           <a:p>
             <a:pPr lvl="1"/>
             <a:r>
-              <a:rPr lang="en-US" smtClean="0"/>
+              <a:rPr lang="en-US"/>
               <a:t>Second level</a:t>
             </a:r>
           </a:p>
           <a:p>
             <a:pPr lvl="2"/>
             <a:r>
-              <a:rPr lang="en-US" smtClean="0"/>
+              <a:rPr lang="en-US"/>
               <a:t>Third level</a:t>
             </a:r>
           </a:p>
           <a:p>
             <a:pPr lvl="3"/>
             <a:r>
-              <a:rPr lang="en-US" smtClean="0"/>
+              <a:rPr lang="en-US"/>
               <a:t>Fourth level</a:t>
             </a:r>
           </a:p>
           <a:p>
             <a:pPr lvl="4"/>
             <a:r>
-              <a:rPr lang="en-US" smtClean="0"/>
+              <a:rPr lang="en-US"/>
               <a:t>Fifth level</a:t>
             </a:r>
-            <a:endParaRPr lang="en-US"/>
           </a:p>
         </p:txBody>
       </p:sp>
@@ -469,7 +481,7 @@
           <a:p>
             <a:fld id="{5BCAD085-E8A6-8845-BD4E-CB4CCA059FC4}" type="datetimeFigureOut">
               <a:rPr lang="en-US" smtClean="0"/>
-              <a:t>1/27/13</a:t>
+              <a:t>5/10/26</a:t>
             </a:fld>
             <a:endParaRPr lang="en-US"/>
           </a:p>
@@ -568,10 +580,9 @@
           <a:lstStyle/>
           <a:p>
             <a:r>
-              <a:rPr lang="en-US" smtClean="0"/>
+              <a:rPr lang="en-US"/>
               <a:t>Click to edit Master title style</a:t>
             </a:r>
-            <a:endParaRPr lang="en-US"/>
           </a:p>
         </p:txBody>
       </p:sp>
@@ -597,38 +608,37 @@
           <a:p>
             <a:pPr lvl="0"/>
             <a:r>
-              <a:rPr lang="en-US" smtClean="0"/>
+              <a:rPr lang="en-US"/>
               <a:t>Click to edit Master text styles</a:t>
             </a:r>
           </a:p>
           <a:p>
             <a:pPr lvl="1"/>
             <a:r>
-              <a:rPr lang="en-US" smtClean="0"/>
+              <a:rPr lang="en-US"/>
               <a:t>Second level</a:t>
             </a:r>
           </a:p>
           <a:p>
             <a:pPr lvl="2"/>
             <a:r>
-              <a:rPr lang="en-US" smtClean="0"/>
+              <a:rPr lang="en-US"/>
               <a:t>Third level</a:t>
             </a:r>
           </a:p>
           <a:p>
             <a:pPr lvl="3"/>
             <a:r>
-              <a:rPr lang="en-US" smtClean="0"/>
+              <a:rPr lang="en-US"/>
               <a:t>Fourth level</a:t>
             </a:r>
           </a:p>
           <a:p>
             <a:pPr lvl="4"/>
             <a:r>
-              <a:rPr lang="en-US" smtClean="0"/>
+              <a:rPr lang="en-US"/>
               <a:t>Fifth level</a:t>
             </a:r>
-            <a:endParaRPr lang="en-US"/>
           </a:p>
         </p:txBody>
       </p:sp>
@@ -649,7 +659,7 @@
           <a:p>
             <a:fld id="{5BCAD085-E8A6-8845-BD4E-CB4CCA059FC4}" type="datetimeFigureOut">
               <a:rPr lang="en-US" smtClean="0"/>
-              <a:t>1/27/13</a:t>
+              <a:t>5/10/26</a:t>
             </a:fld>
             <a:endParaRPr lang="en-US"/>
           </a:p>
@@ -743,10 +753,9 @@
           <a:lstStyle/>
           <a:p>
             <a:r>
-              <a:rPr lang="en-US" smtClean="0"/>
+              <a:rPr lang="en-US"/>
               <a:t>Click to edit Master title style</a:t>
             </a:r>
-            <a:endParaRPr lang="en-US"/>
           </a:p>
         </p:txBody>
       </p:sp>
@@ -767,38 +776,37 @@
           <a:p>
             <a:pPr lvl="0"/>
             <a:r>
-              <a:rPr lang="en-US" smtClean="0"/>
+              <a:rPr lang="en-US"/>
               <a:t>Click to edit Master text styles</a:t>
             </a:r>
           </a:p>
           <a:p>
             <a:pPr lvl="1"/>
             <a:r>
-              <a:rPr lang="en-US" smtClean="0"/>
+              <a:rPr lang="en-US"/>
               <a:t>Second level</a:t>
             </a:r>
           </a:p>
           <a:p>
             <a:pPr lvl="2"/>
             <a:r>
-              <a:rPr lang="en-US" smtClean="0"/>
+              <a:rPr lang="en-US"/>
               <a:t>Third level</a:t>
             </a:r>
           </a:p>
           <a:p>
             <a:pPr lvl="3"/>
             <a:r>
-              <a:rPr lang="en-US" smtClean="0"/>
+              <a:rPr lang="en-US"/>
               <a:t>Fourth level</a:t>
             </a:r>
           </a:p>
           <a:p>
             <a:pPr lvl="4"/>
             <a:r>
-              <a:rPr lang="en-US" smtClean="0"/>
+              <a:rPr lang="en-US"/>
               <a:t>Fifth level</a:t>
             </a:r>
-            <a:endParaRPr lang="en-US"/>
           </a:p>
         </p:txBody>
       </p:sp>
@@ -819,7 +827,7 @@
           <a:p>
             <a:fld id="{5BCAD085-E8A6-8845-BD4E-CB4CCA059FC4}" type="datetimeFigureOut">
               <a:rPr lang="en-US" smtClean="0"/>
-              <a:t>1/27/13</a:t>
+              <a:t>5/10/26</a:t>
             </a:fld>
             <a:endParaRPr lang="en-US"/>
           </a:p>
@@ -922,10 +930,9 @@
           </a:lstStyle>
           <a:p>
             <a:r>
-              <a:rPr lang="en-US" smtClean="0"/>
+              <a:rPr lang="en-US"/>
               <a:t>Click to edit Master title style</a:t>
             </a:r>
-            <a:endParaRPr lang="en-US"/>
           </a:p>
         </p:txBody>
       </p:sp>
@@ -1042,7 +1049,7 @@
           <a:p>
             <a:pPr lvl="0"/>
             <a:r>
-              <a:rPr lang="en-US" smtClean="0"/>
+              <a:rPr lang="en-US"/>
               <a:t>Click to edit Master text styles</a:t>
             </a:r>
           </a:p>
@@ -1065,7 +1072,7 @@
           <a:p>
             <a:fld id="{5BCAD085-E8A6-8845-BD4E-CB4CCA059FC4}" type="datetimeFigureOut">
               <a:rPr lang="en-US" smtClean="0"/>
-              <a:t>1/27/13</a:t>
+              <a:t>5/10/26</a:t>
             </a:fld>
             <a:endParaRPr lang="en-US"/>
           </a:p>
@@ -1159,10 +1166,9 @@
           <a:lstStyle/>
           <a:p>
             <a:r>
-              <a:rPr lang="en-US" smtClean="0"/>
+              <a:rPr lang="en-US"/>
               <a:t>Click to edit Master title style</a:t>
             </a:r>
-            <a:endParaRPr lang="en-US"/>
           </a:p>
         </p:txBody>
       </p:sp>
@@ -1216,38 +1222,37 @@
           <a:p>
             <a:pPr lvl="0"/>
             <a:r>
-              <a:rPr lang="en-US" smtClean="0"/>
+              <a:rPr lang="en-US"/>
               <a:t>Click to edit Master text styles</a:t>
             </a:r>
           </a:p>
           <a:p>
             <a:pPr lvl="1"/>
             <a:r>
-              <a:rPr lang="en-US" smtClean="0"/>
+              <a:rPr lang="en-US"/>
               <a:t>Second level</a:t>
             </a:r>
           </a:p>
           <a:p>
             <a:pPr lvl="2"/>
             <a:r>
-              <a:rPr lang="en-US" smtClean="0"/>
+              <a:rPr lang="en-US"/>
               <a:t>Third level</a:t>
             </a:r>
           </a:p>
           <a:p>
             <a:pPr lvl="3"/>
             <a:r>
-              <a:rPr lang="en-US" smtClean="0"/>
+              <a:rPr lang="en-US"/>
               <a:t>Fourth level</a:t>
             </a:r>
           </a:p>
           <a:p>
             <a:pPr lvl="4"/>
             <a:r>
-              <a:rPr lang="en-US" smtClean="0"/>
+              <a:rPr lang="en-US"/>
               <a:t>Fifth level</a:t>
             </a:r>
-            <a:endParaRPr lang="en-US"/>
           </a:p>
         </p:txBody>
       </p:sp>
@@ -1301,38 +1306,37 @@
           <a:p>
             <a:pPr lvl="0"/>
             <a:r>
-              <a:rPr lang="en-US" smtClean="0"/>
+              <a:rPr lang="en-US"/>
               <a:t>Click to edit Master text styles</a:t>
             </a:r>
           </a:p>
           <a:p>
             <a:pPr lvl="1"/>
             <a:r>
-              <a:rPr lang="en-US" smtClean="0"/>
+              <a:rPr lang="en-US"/>
               <a:t>Second level</a:t>
             </a:r>
           </a:p>
           <a:p>
             <a:pPr lvl="2"/>
             <a:r>
-              <a:rPr lang="en-US" smtClean="0"/>
+              <a:rPr lang="en-US"/>
               <a:t>Third level</a:t>
             </a:r>
           </a:p>
           <a:p>
             <a:pPr lvl="3"/>
             <a:r>
-              <a:rPr lang="en-US" smtClean="0"/>
+              <a:rPr lang="en-US"/>
               <a:t>Fourth level</a:t>
             </a:r>
           </a:p>
           <a:p>
             <a:pPr lvl="4"/>
             <a:r>
-              <a:rPr lang="en-US" smtClean="0"/>
+              <a:rPr lang="en-US"/>
               <a:t>Fifth level</a:t>
             </a:r>
-            <a:endParaRPr lang="en-US"/>
           </a:p>
         </p:txBody>
       </p:sp>
@@ -1353,7 +1357,7 @@
           <a:p>
             <a:fld id="{5BCAD085-E8A6-8845-BD4E-CB4CCA059FC4}" type="datetimeFigureOut">
               <a:rPr lang="en-US" smtClean="0"/>
-              <a:t>1/27/13</a:t>
+              <a:t>5/10/26</a:t>
             </a:fld>
             <a:endParaRPr lang="en-US"/>
           </a:p>
@@ -1451,10 +1455,9 @@
           </a:lstStyle>
           <a:p>
             <a:r>
-              <a:rPr lang="en-US" smtClean="0"/>
+              <a:rPr lang="en-US"/>
               <a:t>Click to edit Master title style</a:t>
             </a:r>
-            <a:endParaRPr lang="en-US"/>
           </a:p>
         </p:txBody>
       </p:sp>
@@ -1517,7 +1520,7 @@
           <a:p>
             <a:pPr lvl="0"/>
             <a:r>
-              <a:rPr lang="en-US" smtClean="0"/>
+              <a:rPr lang="en-US"/>
               <a:t>Click to edit Master text styles</a:t>
             </a:r>
           </a:p>
@@ -1573,38 +1576,37 @@
           <a:p>
             <a:pPr lvl="0"/>
             <a:r>
-              <a:rPr lang="en-US" smtClean="0"/>
+              <a:rPr lang="en-US"/>
               <a:t>Click to edit Master text styles</a:t>
             </a:r>
           </a:p>
           <a:p>
             <a:pPr lvl="1"/>
             <a:r>
-              <a:rPr lang="en-US" smtClean="0"/>
+              <a:rPr lang="en-US"/>
               <a:t>Second level</a:t>
             </a:r>
           </a:p>
           <a:p>
             <a:pPr lvl="2"/>
             <a:r>
-              <a:rPr lang="en-US" smtClean="0"/>
+              <a:rPr lang="en-US"/>
               <a:t>Third level</a:t>
             </a:r>
           </a:p>
           <a:p>
             <a:pPr lvl="3"/>
             <a:r>
-              <a:rPr lang="en-US" smtClean="0"/>
+              <a:rPr lang="en-US"/>
               <a:t>Fourth level</a:t>
             </a:r>
           </a:p>
           <a:p>
             <a:pPr lvl="4"/>
             <a:r>
-              <a:rPr lang="en-US" smtClean="0"/>
+              <a:rPr lang="en-US"/>
               <a:t>Fifth level</a:t>
             </a:r>
-            <a:endParaRPr lang="en-US"/>
           </a:p>
         </p:txBody>
       </p:sp>
@@ -1667,7 +1669,7 @@
           <a:p>
             <a:pPr lvl="0"/>
             <a:r>
-              <a:rPr lang="en-US" smtClean="0"/>
+              <a:rPr lang="en-US"/>
               <a:t>Click to edit Master text styles</a:t>
             </a:r>
           </a:p>
@@ -1723,38 +1725,37 @@
           <a:p>
             <a:pPr lvl="0"/>
             <a:r>
-              <a:rPr lang="en-US" smtClean="0"/>
+              <a:rPr lang="en-US"/>
               <a:t>Click to edit Master text styles</a:t>
             </a:r>
           </a:p>
           <a:p>
             <a:pPr lvl="1"/>
             <a:r>
-              <a:rPr lang="en-US" smtClean="0"/>
+              <a:rPr lang="en-US"/>
               <a:t>Second level</a:t>
             </a:r>
           </a:p>
           <a:p>
             <a:pPr lvl="2"/>
             <a:r>
-              <a:rPr lang="en-US" smtClean="0"/>
+              <a:rPr lang="en-US"/>
               <a:t>Third level</a:t>
             </a:r>
           </a:p>
           <a:p>
             <a:pPr lvl="3"/>
             <a:r>
-              <a:rPr lang="en-US" smtClean="0"/>
+              <a:rPr lang="en-US"/>
               <a:t>Fourth level</a:t>
             </a:r>
           </a:p>
           <a:p>
             <a:pPr lvl="4"/>
             <a:r>
-              <a:rPr lang="en-US" smtClean="0"/>
+              <a:rPr lang="en-US"/>
               <a:t>Fifth level</a:t>
             </a:r>
-            <a:endParaRPr lang="en-US"/>
           </a:p>
         </p:txBody>
       </p:sp>
@@ -1775,7 +1776,7 @@
           <a:p>
             <a:fld id="{5BCAD085-E8A6-8845-BD4E-CB4CCA059FC4}" type="datetimeFigureOut">
               <a:rPr lang="en-US" smtClean="0"/>
-              <a:t>1/27/13</a:t>
+              <a:t>5/10/26</a:t>
             </a:fld>
             <a:endParaRPr lang="en-US"/>
           </a:p>
@@ -1869,10 +1870,9 @@
           <a:lstStyle/>
           <a:p>
             <a:r>
-              <a:rPr lang="en-US" smtClean="0"/>
+              <a:rPr lang="en-US"/>
               <a:t>Click to edit Master title style</a:t>
             </a:r>
-            <a:endParaRPr lang="en-US"/>
           </a:p>
         </p:txBody>
       </p:sp>
@@ -1893,7 +1893,7 @@
           <a:p>
             <a:fld id="{5BCAD085-E8A6-8845-BD4E-CB4CCA059FC4}" type="datetimeFigureOut">
               <a:rPr lang="en-US" smtClean="0"/>
-              <a:t>1/27/13</a:t>
+              <a:t>5/10/26</a:t>
             </a:fld>
             <a:endParaRPr lang="en-US"/>
           </a:p>
@@ -1988,7 +1988,7 @@
           <a:p>
             <a:fld id="{5BCAD085-E8A6-8845-BD4E-CB4CCA059FC4}" type="datetimeFigureOut">
               <a:rPr lang="en-US" smtClean="0"/>
-              <a:t>1/27/13</a:t>
+              <a:t>5/10/26</a:t>
             </a:fld>
             <a:endParaRPr lang="en-US"/>
           </a:p>
@@ -2091,10 +2091,9 @@
           </a:lstStyle>
           <a:p>
             <a:r>
-              <a:rPr lang="en-US" smtClean="0"/>
+              <a:rPr lang="en-US"/>
               <a:t>Click to edit Master title style</a:t>
             </a:r>
-            <a:endParaRPr lang="en-US"/>
           </a:p>
         </p:txBody>
       </p:sp>
@@ -2148,38 +2147,37 @@
           <a:p>
             <a:pPr lvl="0"/>
             <a:r>
-              <a:rPr lang="en-US" smtClean="0"/>
+              <a:rPr lang="en-US"/>
               <a:t>Click to edit Master text styles</a:t>
             </a:r>
           </a:p>
           <a:p>
             <a:pPr lvl="1"/>
             <a:r>
-              <a:rPr lang="en-US" smtClean="0"/>
+              <a:rPr lang="en-US"/>
               <a:t>Second level</a:t>
             </a:r>
           </a:p>
           <a:p>
             <a:pPr lvl="2"/>
             <a:r>
-              <a:rPr lang="en-US" smtClean="0"/>
+              <a:rPr lang="en-US"/>
               <a:t>Third level</a:t>
             </a:r>
           </a:p>
           <a:p>
             <a:pPr lvl="3"/>
             <a:r>
-              <a:rPr lang="en-US" smtClean="0"/>
+              <a:rPr lang="en-US"/>
               <a:t>Fourth level</a:t>
             </a:r>
           </a:p>
           <a:p>
             <a:pPr lvl="4"/>
             <a:r>
-              <a:rPr lang="en-US" smtClean="0"/>
+              <a:rPr lang="en-US"/>
               <a:t>Fifth level</a:t>
             </a:r>
-            <a:endParaRPr lang="en-US"/>
           </a:p>
         </p:txBody>
       </p:sp>
@@ -2242,7 +2240,7 @@
           <a:p>
             <a:pPr lvl="0"/>
             <a:r>
-              <a:rPr lang="en-US" smtClean="0"/>
+              <a:rPr lang="en-US"/>
               <a:t>Click to edit Master text styles</a:t>
             </a:r>
           </a:p>
@@ -2265,7 +2263,7 @@
           <a:p>
             <a:fld id="{5BCAD085-E8A6-8845-BD4E-CB4CCA059FC4}" type="datetimeFigureOut">
               <a:rPr lang="en-US" smtClean="0"/>
-              <a:t>1/27/13</a:t>
+              <a:t>5/10/26</a:t>
             </a:fld>
             <a:endParaRPr lang="en-US"/>
           </a:p>
@@ -2368,10 +2366,9 @@
           </a:lstStyle>
           <a:p>
             <a:r>
-              <a:rPr lang="en-US" smtClean="0"/>
+              <a:rPr lang="en-US"/>
               <a:t>Click to edit Master title style</a:t>
             </a:r>
-            <a:endParaRPr lang="en-US"/>
           </a:p>
         </p:txBody>
       </p:sp>
@@ -2495,7 +2492,7 @@
           <a:p>
             <a:pPr lvl="0"/>
             <a:r>
-              <a:rPr lang="en-US" smtClean="0"/>
+              <a:rPr lang="en-US"/>
               <a:t>Click to edit Master text styles</a:t>
             </a:r>
           </a:p>
@@ -2518,7 +2515,7 @@
           <a:p>
             <a:fld id="{5BCAD085-E8A6-8845-BD4E-CB4CCA059FC4}" type="datetimeFigureOut">
               <a:rPr lang="en-US" smtClean="0"/>
-              <a:t>1/27/13</a:t>
+              <a:t>5/10/26</a:t>
             </a:fld>
             <a:endParaRPr lang="en-US"/>
           </a:p>
@@ -2627,10 +2624,9 @@
           <a:lstStyle/>
           <a:p>
             <a:r>
-              <a:rPr lang="en-US" smtClean="0"/>
+              <a:rPr lang="en-US"/>
               <a:t>Click to edit Master title style</a:t>
             </a:r>
-            <a:endParaRPr lang="en-US"/>
           </a:p>
         </p:txBody>
       </p:sp>
@@ -2661,38 +2657,37 @@
           <a:p>
             <a:pPr lvl="0"/>
             <a:r>
-              <a:rPr lang="en-US" smtClean="0"/>
+              <a:rPr lang="en-US"/>
               <a:t>Click to edit Master text styles</a:t>
             </a:r>
           </a:p>
           <a:p>
             <a:pPr lvl="1"/>
             <a:r>
-              <a:rPr lang="en-US" smtClean="0"/>
+              <a:rPr lang="en-US"/>
               <a:t>Second level</a:t>
             </a:r>
           </a:p>
           <a:p>
             <a:pPr lvl="2"/>
             <a:r>
-              <a:rPr lang="en-US" smtClean="0"/>
+              <a:rPr lang="en-US"/>
               <a:t>Third level</a:t>
             </a:r>
           </a:p>
           <a:p>
             <a:pPr lvl="3"/>
             <a:r>
-              <a:rPr lang="en-US" smtClean="0"/>
+              <a:rPr lang="en-US"/>
               <a:t>Fourth level</a:t>
             </a:r>
           </a:p>
           <a:p>
             <a:pPr lvl="4"/>
             <a:r>
-              <a:rPr lang="en-US" smtClean="0"/>
+              <a:rPr lang="en-US"/>
               <a:t>Fifth level</a:t>
             </a:r>
-            <a:endParaRPr lang="en-US"/>
           </a:p>
         </p:txBody>
       </p:sp>
@@ -2731,7 +2726,7 @@
           <a:p>
             <a:fld id="{5BCAD085-E8A6-8845-BD4E-CB4CCA059FC4}" type="datetimeFigureOut">
               <a:rPr lang="en-US" smtClean="0"/>
-              <a:t>1/27/13</a:t>
+              <a:t>5/10/26</a:t>
             </a:fld>
             <a:endParaRPr lang="en-US"/>
           </a:p>
@@ -3090,7 +3085,7 @@
 </file>
 
 <file path=ppt/slides/slide1.xml><?xml version="1.0" encoding="utf-8"?>
-<p:sld xmlns:a="http://schemas.openxmlformats.org/drawingml/2006/main" xmlns:p="http://schemas.openxmlformats.org/presentationml/2006/main" xmlns:r="http://schemas.openxmlformats.org/officeDocument/2006/relationships">
+<p:sld xmlns:a="http://schemas.openxmlformats.org/drawingml/2006/main" xmlns:r="http://schemas.openxmlformats.org/officeDocument/2006/relationships" xmlns:p="http://schemas.openxmlformats.org/presentationml/2006/main">
   <p:cSld>
     <p:spTree>
       <p:nvGrpSpPr>
@@ -3098,7 +3093,14 @@
         <p:cNvGrpSpPr/>
         <p:nvPr/>
       </p:nvGrpSpPr>
-      <p:grpSpPr/>
+      <p:grpSpPr>
+        <a:xfrm>
+          <a:off x="0" y="0"/>
+          <a:ext cx="0" cy="0"/>
+          <a:chOff x="0" y="0"/>
+          <a:chExt cx="0" cy="0"/>
+        </a:xfrm>
+      </p:grpSpPr>
       <p:sp>
         <p:nvSpPr>
           <p:cNvPr id="2" name="Rectangle 1"/>
@@ -3139,6 +3141,7 @@
           <a:lstStyle/>
           <a:p>
             <a:pPr algn="ctr"/>
+            <a:endParaRPr/>
           </a:p>
         </p:txBody>
       </p:sp>
@@ -3182,6 +3185,7 @@
           <a:lstStyle/>
           <a:p>
             <a:pPr algn="ctr"/>
+            <a:endParaRPr/>
           </a:p>
         </p:txBody>
       </p:sp>
@@ -3225,6 +3229,7 @@
           <a:lstStyle/>
           <a:p>
             <a:pPr algn="ctr"/>
+            <a:endParaRPr/>
           </a:p>
         </p:txBody>
       </p:sp>
@@ -3410,6 +3415,7 @@
           <a:lstStyle/>
           <a:p>
             <a:pPr algn="ctr"/>
+            <a:endParaRPr/>
           </a:p>
         </p:txBody>
       </p:sp>
@@ -3422,7 +3428,7 @@
 </file>
 
 <file path=ppt/slides/slide10.xml><?xml version="1.0" encoding="utf-8"?>
-<p:sld xmlns:a="http://schemas.openxmlformats.org/drawingml/2006/main" xmlns:p="http://schemas.openxmlformats.org/presentationml/2006/main" xmlns:r="http://schemas.openxmlformats.org/officeDocument/2006/relationships">
+<p:sld xmlns:a="http://schemas.openxmlformats.org/drawingml/2006/main" xmlns:r="http://schemas.openxmlformats.org/officeDocument/2006/relationships" xmlns:p="http://schemas.openxmlformats.org/presentationml/2006/main">
   <p:cSld>
     <p:spTree>
       <p:nvGrpSpPr>
@@ -3430,7 +3436,14 @@
         <p:cNvGrpSpPr/>
         <p:nvPr/>
       </p:nvGrpSpPr>
-      <p:grpSpPr/>
+      <p:grpSpPr>
+        <a:xfrm>
+          <a:off x="0" y="0"/>
+          <a:ext cx="0" cy="0"/>
+          <a:chOff x="0" y="0"/>
+          <a:chExt cx="0" cy="0"/>
+        </a:xfrm>
+      </p:grpSpPr>
       <p:sp>
         <p:nvSpPr>
           <p:cNvPr id="2" name="Rectangle 1"/>
@@ -3471,6 +3484,7 @@
           <a:lstStyle/>
           <a:p>
             <a:pPr algn="ctr"/>
+            <a:endParaRPr/>
           </a:p>
         </p:txBody>
       </p:sp>
@@ -3549,6 +3563,7 @@
           <a:lstStyle/>
           <a:p>
             <a:pPr algn="ctr"/>
+            <a:endParaRPr/>
           </a:p>
         </p:txBody>
       </p:sp>
@@ -3700,6 +3715,7 @@
           <a:lstStyle/>
           <a:p>
             <a:pPr algn="ctr"/>
+            <a:endParaRPr/>
           </a:p>
         </p:txBody>
       </p:sp>
@@ -3815,6 +3831,7 @@
           <a:lstStyle/>
           <a:p>
             <a:pPr algn="ctr"/>
+            <a:endParaRPr/>
           </a:p>
         </p:txBody>
       </p:sp>
@@ -3930,6 +3947,7 @@
           <a:lstStyle/>
           <a:p>
             <a:pPr algn="ctr"/>
+            <a:endParaRPr/>
           </a:p>
         </p:txBody>
       </p:sp>
@@ -4045,6 +4063,7 @@
           <a:lstStyle/>
           <a:p>
             <a:pPr algn="ctr"/>
+            <a:endParaRPr/>
           </a:p>
         </p:txBody>
       </p:sp>
@@ -4162,7 +4181,7 @@
 </file>
 
 <file path=ppt/slides/slide11.xml><?xml version="1.0" encoding="utf-8"?>
-<p:sld xmlns:a="http://schemas.openxmlformats.org/drawingml/2006/main" xmlns:p="http://schemas.openxmlformats.org/presentationml/2006/main" xmlns:r="http://schemas.openxmlformats.org/officeDocument/2006/relationships">
+<p:sld xmlns:a="http://schemas.openxmlformats.org/drawingml/2006/main" xmlns:r="http://schemas.openxmlformats.org/officeDocument/2006/relationships" xmlns:p="http://schemas.openxmlformats.org/presentationml/2006/main">
   <p:cSld>
     <p:spTree>
       <p:nvGrpSpPr>
@@ -4170,7 +4189,14 @@
         <p:cNvGrpSpPr/>
         <p:nvPr/>
       </p:nvGrpSpPr>
-      <p:grpSpPr/>
+      <p:grpSpPr>
+        <a:xfrm>
+          <a:off x="0" y="0"/>
+          <a:ext cx="0" cy="0"/>
+          <a:chOff x="0" y="0"/>
+          <a:chExt cx="0" cy="0"/>
+        </a:xfrm>
+      </p:grpSpPr>
       <p:sp>
         <p:nvSpPr>
           <p:cNvPr id="2" name="Rectangle 1"/>
@@ -4211,6 +4237,7 @@
           <a:lstStyle/>
           <a:p>
             <a:pPr algn="ctr"/>
+            <a:endParaRPr/>
           </a:p>
         </p:txBody>
       </p:sp>
@@ -4289,6 +4316,7 @@
           <a:lstStyle/>
           <a:p>
             <a:pPr algn="ctr"/>
+            <a:endParaRPr/>
           </a:p>
         </p:txBody>
       </p:sp>
@@ -4542,6 +4570,7 @@
           <a:lstStyle/>
           <a:p>
             <a:pPr algn="ctr"/>
+            <a:endParaRPr/>
           </a:p>
         </p:txBody>
       </p:sp>
@@ -4690,6 +4719,7 @@
           <a:lstStyle/>
           <a:p>
             <a:pPr algn="ctr"/>
+            <a:endParaRPr/>
           </a:p>
         </p:txBody>
       </p:sp>
@@ -4838,6 +4868,7 @@
           <a:lstStyle/>
           <a:p>
             <a:pPr algn="ctr"/>
+            <a:endParaRPr/>
           </a:p>
         </p:txBody>
       </p:sp>
@@ -4986,6 +5017,7 @@
           <a:lstStyle/>
           <a:p>
             <a:pPr algn="ctr"/>
+            <a:endParaRPr/>
           </a:p>
         </p:txBody>
       </p:sp>
@@ -5103,7 +5135,7 @@
 </file>
 
 <file path=ppt/slides/slide12.xml><?xml version="1.0" encoding="utf-8"?>
-<p:sld xmlns:a="http://schemas.openxmlformats.org/drawingml/2006/main" xmlns:p="http://schemas.openxmlformats.org/presentationml/2006/main" xmlns:r="http://schemas.openxmlformats.org/officeDocument/2006/relationships">
+<p:sld xmlns:a="http://schemas.openxmlformats.org/drawingml/2006/main" xmlns:r="http://schemas.openxmlformats.org/officeDocument/2006/relationships" xmlns:p="http://schemas.openxmlformats.org/presentationml/2006/main">
   <p:cSld>
     <p:spTree>
       <p:nvGrpSpPr>
@@ -5111,7 +5143,14 @@
         <p:cNvGrpSpPr/>
         <p:nvPr/>
       </p:nvGrpSpPr>
-      <p:grpSpPr/>
+      <p:grpSpPr>
+        <a:xfrm>
+          <a:off x="0" y="0"/>
+          <a:ext cx="0" cy="0"/>
+          <a:chOff x="0" y="0"/>
+          <a:chExt cx="0" cy="0"/>
+        </a:xfrm>
+      </p:grpSpPr>
       <p:sp>
         <p:nvSpPr>
           <p:cNvPr id="2" name="Rectangle 1"/>
@@ -5152,6 +5191,7 @@
           <a:lstStyle/>
           <a:p>
             <a:pPr algn="ctr"/>
+            <a:endParaRPr/>
           </a:p>
         </p:txBody>
       </p:sp>
@@ -5195,6 +5235,7 @@
           <a:lstStyle/>
           <a:p>
             <a:pPr algn="ctr"/>
+            <a:endParaRPr/>
           </a:p>
         </p:txBody>
       </p:sp>
@@ -5273,6 +5314,7 @@
           <a:lstStyle/>
           <a:p>
             <a:pPr algn="ctr"/>
+            <a:endParaRPr/>
           </a:p>
         </p:txBody>
       </p:sp>
@@ -5460,6 +5502,7 @@
           <a:lstStyle/>
           <a:p>
             <a:pPr algn="ctr"/>
+            <a:endParaRPr/>
           </a:p>
         </p:txBody>
       </p:sp>
@@ -5575,6 +5618,7 @@
           <a:lstStyle/>
           <a:p>
             <a:pPr algn="ctr"/>
+            <a:endParaRPr/>
           </a:p>
         </p:txBody>
       </p:sp>
@@ -5690,6 +5734,7 @@
           <a:lstStyle/>
           <a:p>
             <a:pPr algn="ctr"/>
+            <a:endParaRPr/>
           </a:p>
         </p:txBody>
       </p:sp>
@@ -5842,7 +5887,7 @@
 </file>
 
 <file path=ppt/slides/slide2.xml><?xml version="1.0" encoding="utf-8"?>
-<p:sld xmlns:a="http://schemas.openxmlformats.org/drawingml/2006/main" xmlns:p="http://schemas.openxmlformats.org/presentationml/2006/main" xmlns:r="http://schemas.openxmlformats.org/officeDocument/2006/relationships">
+<p:sld xmlns:a="http://schemas.openxmlformats.org/drawingml/2006/main" xmlns:r="http://schemas.openxmlformats.org/officeDocument/2006/relationships" xmlns:p="http://schemas.openxmlformats.org/presentationml/2006/main">
   <p:cSld>
     <p:spTree>
       <p:nvGrpSpPr>
@@ -5850,7 +5895,14 @@
         <p:cNvGrpSpPr/>
         <p:nvPr/>
       </p:nvGrpSpPr>
-      <p:grpSpPr/>
+      <p:grpSpPr>
+        <a:xfrm>
+          <a:off x="0" y="0"/>
+          <a:ext cx="0" cy="0"/>
+          <a:chOff x="0" y="0"/>
+          <a:chExt cx="0" cy="0"/>
+        </a:xfrm>
+      </p:grpSpPr>
       <p:sp>
         <p:nvSpPr>
           <p:cNvPr id="2" name="Rectangle 1"/>
@@ -5891,6 +5943,7 @@
           <a:lstStyle/>
           <a:p>
             <a:pPr algn="ctr"/>
+            <a:endParaRPr/>
           </a:p>
         </p:txBody>
       </p:sp>
@@ -5969,6 +6022,7 @@
           <a:lstStyle/>
           <a:p>
             <a:pPr algn="ctr"/>
+            <a:endParaRPr/>
           </a:p>
         </p:txBody>
       </p:sp>
@@ -6087,7 +6141,7 @@
         <p:spPr>
           <a:xfrm>
             <a:off x="548640" y="2743200"/>
-            <a:ext cx="5943600" cy="2286000"/>
+            <a:ext cx="5943600" cy="2477601"/>
           </a:xfrm>
           <a:prstGeom prst="rect">
             <a:avLst/>
@@ -6106,13 +6160,31 @@
               </a:spcBef>
             </a:pPr>
             <a:r>
-              <a:rPr sz="1500">
+              <a:rPr sz="1500" dirty="0">
                 <a:solidFill>
                   <a:srgbClr val="4A5668"/>
                 </a:solidFill>
                 <a:latin typeface="Manrope"/>
               </a:rPr>
-              <a:t>  Brands spend 40–60% of revenue on ads with declining returns</a:t>
+              <a:t>Brands spend 40–60% of revenue on ads</a:t>
+            </a:r>
+            <a:r>
+              <a:rPr lang="en-US" sz="1500" dirty="0">
+                <a:solidFill>
+                  <a:srgbClr val="4A5668"/>
+                </a:solidFill>
+                <a:latin typeface="Manrope"/>
+              </a:rPr>
+              <a:t>, distribution, wholesale/retail channels</a:t>
+            </a:r>
+            <a:r>
+              <a:rPr sz="1500" dirty="0">
+                <a:solidFill>
+                  <a:srgbClr val="4A5668"/>
+                </a:solidFill>
+                <a:latin typeface="Manrope"/>
+              </a:rPr>
+              <a:t> with declining returns</a:t>
             </a:r>
           </a:p>
           <a:p>
@@ -6121,15 +6193,12 @@
                 <a:spcPts val="400"/>
               </a:spcBef>
             </a:pPr>
-            <a:r>
-              <a:rPr sz="1500">
-                <a:solidFill>
-                  <a:srgbClr val="4A5668"/>
-                </a:solidFill>
-                <a:latin typeface="Manrope"/>
-              </a:rPr>
-              <a:t>  Practitioners give away billions in purchasing influence — for free</a:t>
-            </a:r>
+            <a:endParaRPr lang="en-US" sz="1500" dirty="0">
+              <a:solidFill>
+                <a:srgbClr val="4A5668"/>
+              </a:solidFill>
+              <a:latin typeface="Manrope"/>
+            </a:endParaRPr>
           </a:p>
           <a:p>
             <a:pPr algn="l">
@@ -6138,13 +6207,13 @@
               </a:spcBef>
             </a:pPr>
             <a:r>
-              <a:rPr sz="1500">
+              <a:rPr sz="1500" dirty="0">
                 <a:solidFill>
                   <a:srgbClr val="4A5668"/>
                 </a:solidFill>
                 <a:latin typeface="Manrope"/>
               </a:rPr>
-              <a:t>  Patients buy from Amazon based on reviews instead of their doctor's advice</a:t>
+              <a:t>Practitioners give away billions in purchasing influence — for free</a:t>
             </a:r>
           </a:p>
           <a:p>
@@ -6153,14 +6222,56 @@
                 <a:spcPts val="400"/>
               </a:spcBef>
             </a:pPr>
-            <a:r>
-              <a:rPr sz="1500">
+            <a:endParaRPr lang="en-US" sz="1500" dirty="0">
+              <a:solidFill>
+                <a:srgbClr val="4A5668"/>
+              </a:solidFill>
+              <a:latin typeface="Manrope"/>
+            </a:endParaRPr>
+          </a:p>
+          <a:p>
+            <a:pPr algn="l">
+              <a:spcBef>
+                <a:spcPts val="400"/>
+              </a:spcBef>
+            </a:pPr>
+            <a:r>
+              <a:rPr sz="1500" dirty="0">
                 <a:solidFill>
                   <a:srgbClr val="4A5668"/>
                 </a:solidFill>
                 <a:latin typeface="Manrope"/>
               </a:rPr>
-              <a:t>  No infrastructure connects trust → recommendation → purchase at scale</a:t>
+              <a:t>Patients buy from Amazon based on reviews instead of their doctor's advice</a:t>
+            </a:r>
+          </a:p>
+          <a:p>
+            <a:pPr algn="l">
+              <a:spcBef>
+                <a:spcPts val="400"/>
+              </a:spcBef>
+            </a:pPr>
+            <a:endParaRPr lang="en-US" sz="1500" dirty="0">
+              <a:solidFill>
+                <a:srgbClr val="4A5668"/>
+              </a:solidFill>
+              <a:latin typeface="Manrope"/>
+            </a:endParaRPr>
+          </a:p>
+          <a:p>
+            <a:pPr algn="l">
+              <a:spcBef>
+                <a:spcPts val="400"/>
+              </a:spcBef>
+            </a:pPr>
+            <a:r>
+              <a:rPr sz="1500" dirty="0">
+                <a:solidFill>
+                  <a:srgbClr val="4A5668"/>
+                </a:solidFill>
+                <a:latin typeface="Manrope"/>
+              </a:rPr>
+              <a:t>No infrastructure connects trust → recommendation → purchase at scale</a:t>
             </a:r>
           </a:p>
         </p:txBody>
@@ -6207,6 +6318,7 @@
           <a:lstStyle/>
           <a:p>
             <a:pPr algn="ctr"/>
+            <a:endParaRPr/>
           </a:p>
         </p:txBody>
       </p:sp>
@@ -6362,7 +6474,7 @@
 </file>
 
 <file path=ppt/slides/slide3.xml><?xml version="1.0" encoding="utf-8"?>
-<p:sld xmlns:a="http://schemas.openxmlformats.org/drawingml/2006/main" xmlns:p="http://schemas.openxmlformats.org/presentationml/2006/main" xmlns:r="http://schemas.openxmlformats.org/officeDocument/2006/relationships">
+<p:sld xmlns:a="http://schemas.openxmlformats.org/drawingml/2006/main" xmlns:r="http://schemas.openxmlformats.org/officeDocument/2006/relationships" xmlns:p="http://schemas.openxmlformats.org/presentationml/2006/main">
   <p:cSld>
     <p:spTree>
       <p:nvGrpSpPr>
@@ -6370,7 +6482,14 @@
         <p:cNvGrpSpPr/>
         <p:nvPr/>
       </p:nvGrpSpPr>
-      <p:grpSpPr/>
+      <p:grpSpPr>
+        <a:xfrm>
+          <a:off x="0" y="0"/>
+          <a:ext cx="0" cy="0"/>
+          <a:chOff x="0" y="0"/>
+          <a:chExt cx="0" cy="0"/>
+        </a:xfrm>
+      </p:grpSpPr>
       <p:sp>
         <p:nvSpPr>
           <p:cNvPr id="2" name="Rectangle 1"/>
@@ -6411,6 +6530,7 @@
           <a:lstStyle/>
           <a:p>
             <a:pPr algn="ctr"/>
+            <a:endParaRPr/>
           </a:p>
         </p:txBody>
       </p:sp>
@@ -6489,6 +6609,7 @@
           <a:lstStyle/>
           <a:p>
             <a:pPr algn="ctr"/>
+            <a:endParaRPr/>
           </a:p>
         </p:txBody>
       </p:sp>
@@ -6640,6 +6761,7 @@
           <a:lstStyle/>
           <a:p>
             <a:pPr algn="ctr"/>
+            <a:endParaRPr/>
           </a:p>
         </p:txBody>
       </p:sp>
@@ -6790,6 +6912,7 @@
           <a:lstStyle/>
           <a:p>
             <a:pPr algn="ctr"/>
+            <a:endParaRPr/>
           </a:p>
         </p:txBody>
       </p:sp>
@@ -6940,6 +7063,7 @@
           <a:lstStyle/>
           <a:p>
             <a:pPr algn="ctr"/>
+            <a:endParaRPr/>
           </a:p>
         </p:txBody>
       </p:sp>
@@ -7057,7 +7181,7 @@
 </file>
 
 <file path=ppt/slides/slide4.xml><?xml version="1.0" encoding="utf-8"?>
-<p:sld xmlns:a="http://schemas.openxmlformats.org/drawingml/2006/main" xmlns:p="http://schemas.openxmlformats.org/presentationml/2006/main" xmlns:r="http://schemas.openxmlformats.org/officeDocument/2006/relationships">
+<p:sld xmlns:a="http://schemas.openxmlformats.org/drawingml/2006/main" xmlns:r="http://schemas.openxmlformats.org/officeDocument/2006/relationships" xmlns:p="http://schemas.openxmlformats.org/presentationml/2006/main">
   <p:cSld>
     <p:spTree>
       <p:nvGrpSpPr>
@@ -7065,7 +7189,14 @@
         <p:cNvGrpSpPr/>
         <p:nvPr/>
       </p:nvGrpSpPr>
-      <p:grpSpPr/>
+      <p:grpSpPr>
+        <a:xfrm>
+          <a:off x="0" y="0"/>
+          <a:ext cx="0" cy="0"/>
+          <a:chOff x="0" y="0"/>
+          <a:chExt cx="0" cy="0"/>
+        </a:xfrm>
+      </p:grpSpPr>
       <p:sp>
         <p:nvSpPr>
           <p:cNvPr id="2" name="Rectangle 1"/>
@@ -7106,6 +7237,7 @@
           <a:lstStyle/>
           <a:p>
             <a:pPr algn="ctr"/>
+            <a:endParaRPr/>
           </a:p>
         </p:txBody>
       </p:sp>
@@ -7184,6 +7316,7 @@
           <a:lstStyle/>
           <a:p>
             <a:pPr algn="ctr"/>
+            <a:endParaRPr/>
           </a:p>
         </p:txBody>
       </p:sp>
@@ -7335,6 +7468,7 @@
           <a:lstStyle/>
           <a:p>
             <a:pPr algn="ctr"/>
+            <a:endParaRPr/>
           </a:p>
         </p:txBody>
       </p:sp>
@@ -7485,6 +7619,7 @@
           <a:lstStyle/>
           <a:p>
             <a:pPr algn="ctr"/>
+            <a:endParaRPr/>
           </a:p>
         </p:txBody>
       </p:sp>
@@ -7635,6 +7770,7 @@
           <a:lstStyle/>
           <a:p>
             <a:pPr algn="ctr"/>
+            <a:endParaRPr/>
           </a:p>
         </p:txBody>
       </p:sp>
@@ -7785,6 +7921,7 @@
           <a:lstStyle/>
           <a:p>
             <a:pPr algn="ctr"/>
+            <a:endParaRPr/>
           </a:p>
         </p:txBody>
       </p:sp>
@@ -7902,7 +8039,7 @@
 </file>
 
 <file path=ppt/slides/slide5.xml><?xml version="1.0" encoding="utf-8"?>
-<p:sld xmlns:a="http://schemas.openxmlformats.org/drawingml/2006/main" xmlns:p="http://schemas.openxmlformats.org/presentationml/2006/main" xmlns:r="http://schemas.openxmlformats.org/officeDocument/2006/relationships">
+<p:sld xmlns:a="http://schemas.openxmlformats.org/drawingml/2006/main" xmlns:r="http://schemas.openxmlformats.org/officeDocument/2006/relationships" xmlns:p="http://schemas.openxmlformats.org/presentationml/2006/main">
   <p:cSld>
     <p:spTree>
       <p:nvGrpSpPr>
@@ -7910,7 +8047,14 @@
         <p:cNvGrpSpPr/>
         <p:nvPr/>
       </p:nvGrpSpPr>
-      <p:grpSpPr/>
+      <p:grpSpPr>
+        <a:xfrm>
+          <a:off x="0" y="0"/>
+          <a:ext cx="0" cy="0"/>
+          <a:chOff x="0" y="0"/>
+          <a:chExt cx="0" cy="0"/>
+        </a:xfrm>
+      </p:grpSpPr>
       <p:sp>
         <p:nvSpPr>
           <p:cNvPr id="2" name="Rectangle 1"/>
@@ -7951,6 +8095,7 @@
           <a:lstStyle/>
           <a:p>
             <a:pPr algn="ctr"/>
+            <a:endParaRPr/>
           </a:p>
         </p:txBody>
       </p:sp>
@@ -8029,6 +8174,7 @@
           <a:lstStyle/>
           <a:p>
             <a:pPr algn="ctr"/>
+            <a:endParaRPr/>
           </a:p>
         </p:txBody>
       </p:sp>
@@ -8157,15 +8303,39 @@
                 <a:tableStyleId>{5C22544A-7EE6-4342-B048-85BDC9FD1C3A}</a:tableStyleId>
               </a:tblPr>
               <a:tblGrid>
-                <a:gridCol w="2926080"/>
-                <a:gridCol w="3108960"/>
-                <a:gridCol w="2286000"/>
-                <a:gridCol w="2743200"/>
+                <a:gridCol w="2926080">
+                  <a:extLst>
+                    <a:ext uri="{9D8B030D-6E8A-4147-A177-3AD203B41FA5}">
+                      <a16:colId xmlns:a16="http://schemas.microsoft.com/office/drawing/2014/main" val="20000"/>
+                    </a:ext>
+                  </a:extLst>
+                </a:gridCol>
+                <a:gridCol w="3108960">
+                  <a:extLst>
+                    <a:ext uri="{9D8B030D-6E8A-4147-A177-3AD203B41FA5}">
+                      <a16:colId xmlns:a16="http://schemas.microsoft.com/office/drawing/2014/main" val="20001"/>
+                    </a:ext>
+                  </a:extLst>
+                </a:gridCol>
+                <a:gridCol w="2286000">
+                  <a:extLst>
+                    <a:ext uri="{9D8B030D-6E8A-4147-A177-3AD203B41FA5}">
+                      <a16:colId xmlns:a16="http://schemas.microsoft.com/office/drawing/2014/main" val="20002"/>
+                    </a:ext>
+                  </a:extLst>
+                </a:gridCol>
+                <a:gridCol w="2743200">
+                  <a:extLst>
+                    <a:ext uri="{9D8B030D-6E8A-4147-A177-3AD203B41FA5}">
+                      <a16:colId xmlns:a16="http://schemas.microsoft.com/office/drawing/2014/main" val="20003"/>
+                    </a:ext>
+                  </a:extLst>
+                </a:gridCol>
               </a:tblGrid>
               <a:tr h="384048">
                 <a:tc>
                   <a:txBody>
-                    <a:bodyPr wrap="square"/>
+                    <a:bodyPr/>
                     <a:lstStyle/>
                     <a:p>
                       <a:pPr algn="ctr"/>
@@ -8188,7 +8358,7 @@
                 </a:tc>
                 <a:tc>
                   <a:txBody>
-                    <a:bodyPr wrap="square"/>
+                    <a:bodyPr/>
                     <a:lstStyle/>
                     <a:p>
                       <a:pPr algn="ctr"/>
@@ -8211,7 +8381,7 @@
                 </a:tc>
                 <a:tc>
                   <a:txBody>
-                    <a:bodyPr wrap="square"/>
+                    <a:bodyPr/>
                     <a:lstStyle/>
                     <a:p>
                       <a:pPr algn="ctr"/>
@@ -8234,7 +8404,7 @@
                 </a:tc>
                 <a:tc>
                   <a:txBody>
-                    <a:bodyPr wrap="square"/>
+                    <a:bodyPr/>
                     <a:lstStyle/>
                     <a:p>
                       <a:pPr algn="ctr"/>
@@ -8255,11 +8425,16 @@
                     </a:solidFill>
                   </a:tcPr>
                 </a:tc>
+                <a:extLst>
+                  <a:ext uri="{0D108BD9-81ED-4DB2-BD59-A6C34878D82A}">
+                    <a16:rowId xmlns:a16="http://schemas.microsoft.com/office/drawing/2014/main" val="10000"/>
+                  </a:ext>
+                </a:extLst>
               </a:tr>
               <a:tr h="384048">
                 <a:tc>
                   <a:txBody>
-                    <a:bodyPr wrap="square"/>
+                    <a:bodyPr/>
                     <a:lstStyle/>
                     <a:p>
                       <a:pPr algn="l"/>
@@ -8282,7 +8457,7 @@
                 </a:tc>
                 <a:tc>
                   <a:txBody>
-                    <a:bodyPr wrap="square"/>
+                    <a:bodyPr/>
                     <a:lstStyle/>
                     <a:p>
                       <a:pPr algn="ctr"/>
@@ -8305,7 +8480,7 @@
                 </a:tc>
                 <a:tc>
                   <a:txBody>
-                    <a:bodyPr wrap="square"/>
+                    <a:bodyPr/>
                     <a:lstStyle/>
                     <a:p>
                       <a:pPr algn="ctr"/>
@@ -8328,7 +8503,7 @@
                 </a:tc>
                 <a:tc>
                   <a:txBody>
-                    <a:bodyPr wrap="square"/>
+                    <a:bodyPr/>
                     <a:lstStyle/>
                     <a:p>
                       <a:pPr algn="ctr"/>
@@ -8349,11 +8524,16 @@
                     </a:solidFill>
                   </a:tcPr>
                 </a:tc>
+                <a:extLst>
+                  <a:ext uri="{0D108BD9-81ED-4DB2-BD59-A6C34878D82A}">
+                    <a16:rowId xmlns:a16="http://schemas.microsoft.com/office/drawing/2014/main" val="10001"/>
+                  </a:ext>
+                </a:extLst>
               </a:tr>
               <a:tr h="384048">
                 <a:tc>
                   <a:txBody>
-                    <a:bodyPr wrap="square"/>
+                    <a:bodyPr/>
                     <a:lstStyle/>
                     <a:p>
                       <a:pPr algn="l"/>
@@ -8376,7 +8556,7 @@
                 </a:tc>
                 <a:tc>
                   <a:txBody>
-                    <a:bodyPr wrap="square"/>
+                    <a:bodyPr/>
                     <a:lstStyle/>
                     <a:p>
                       <a:pPr algn="ctr"/>
@@ -8399,7 +8579,7 @@
                 </a:tc>
                 <a:tc>
                   <a:txBody>
-                    <a:bodyPr wrap="square"/>
+                    <a:bodyPr/>
                     <a:lstStyle/>
                     <a:p>
                       <a:pPr algn="ctr"/>
@@ -8422,7 +8602,7 @@
                 </a:tc>
                 <a:tc>
                   <a:txBody>
-                    <a:bodyPr wrap="square"/>
+                    <a:bodyPr/>
                     <a:lstStyle/>
                     <a:p>
                       <a:pPr algn="ctr"/>
@@ -8443,11 +8623,16 @@
                     </a:solidFill>
                   </a:tcPr>
                 </a:tc>
+                <a:extLst>
+                  <a:ext uri="{0D108BD9-81ED-4DB2-BD59-A6C34878D82A}">
+                    <a16:rowId xmlns:a16="http://schemas.microsoft.com/office/drawing/2014/main" val="10002"/>
+                  </a:ext>
+                </a:extLst>
               </a:tr>
               <a:tr h="384048">
                 <a:tc>
                   <a:txBody>
-                    <a:bodyPr wrap="square"/>
+                    <a:bodyPr/>
                     <a:lstStyle/>
                     <a:p>
                       <a:pPr algn="l"/>
@@ -8470,7 +8655,7 @@
                 </a:tc>
                 <a:tc>
                   <a:txBody>
-                    <a:bodyPr wrap="square"/>
+                    <a:bodyPr/>
                     <a:lstStyle/>
                     <a:p>
                       <a:pPr algn="ctr"/>
@@ -8493,7 +8678,7 @@
                 </a:tc>
                 <a:tc>
                   <a:txBody>
-                    <a:bodyPr wrap="square"/>
+                    <a:bodyPr/>
                     <a:lstStyle/>
                     <a:p>
                       <a:pPr algn="ctr"/>
@@ -8516,7 +8701,7 @@
                 </a:tc>
                 <a:tc>
                   <a:txBody>
-                    <a:bodyPr wrap="square"/>
+                    <a:bodyPr/>
                     <a:lstStyle/>
                     <a:p>
                       <a:pPr algn="ctr"/>
@@ -8537,6 +8722,11 @@
                     </a:solidFill>
                   </a:tcPr>
                 </a:tc>
+                <a:extLst>
+                  <a:ext uri="{0D108BD9-81ED-4DB2-BD59-A6C34878D82A}">
+                    <a16:rowId xmlns:a16="http://schemas.microsoft.com/office/drawing/2014/main" val="10003"/>
+                  </a:ext>
+                </a:extLst>
               </a:tr>
             </a:tbl>
           </a:graphicData>
@@ -8586,7 +8776,7 @@
 </file>
 
 <file path=ppt/slides/slide6.xml><?xml version="1.0" encoding="utf-8"?>
-<p:sld xmlns:a="http://schemas.openxmlformats.org/drawingml/2006/main" xmlns:p="http://schemas.openxmlformats.org/presentationml/2006/main" xmlns:r="http://schemas.openxmlformats.org/officeDocument/2006/relationships">
+<p:sld xmlns:a="http://schemas.openxmlformats.org/drawingml/2006/main" xmlns:r="http://schemas.openxmlformats.org/officeDocument/2006/relationships" xmlns:p="http://schemas.openxmlformats.org/presentationml/2006/main">
   <p:cSld>
     <p:spTree>
       <p:nvGrpSpPr>
@@ -8594,7 +8784,14 @@
         <p:cNvGrpSpPr/>
         <p:nvPr/>
       </p:nvGrpSpPr>
-      <p:grpSpPr/>
+      <p:grpSpPr>
+        <a:xfrm>
+          <a:off x="0" y="0"/>
+          <a:ext cx="0" cy="0"/>
+          <a:chOff x="0" y="0"/>
+          <a:chExt cx="0" cy="0"/>
+        </a:xfrm>
+      </p:grpSpPr>
       <p:sp>
         <p:nvSpPr>
           <p:cNvPr id="2" name="Rectangle 1"/>
@@ -8635,6 +8832,7 @@
           <a:lstStyle/>
           <a:p>
             <a:pPr algn="ctr"/>
+            <a:endParaRPr/>
           </a:p>
         </p:txBody>
       </p:sp>
@@ -8678,6 +8876,7 @@
           <a:lstStyle/>
           <a:p>
             <a:pPr algn="ctr"/>
+            <a:endParaRPr/>
           </a:p>
         </p:txBody>
       </p:sp>
@@ -8756,6 +8955,7 @@
           <a:lstStyle/>
           <a:p>
             <a:pPr algn="ctr"/>
+            <a:endParaRPr/>
           </a:p>
         </p:txBody>
       </p:sp>
@@ -9026,6 +9226,7 @@
           <a:lstStyle/>
           <a:p>
             <a:pPr algn="ctr"/>
+            <a:endParaRPr/>
           </a:p>
         </p:txBody>
       </p:sp>
@@ -9110,7 +9311,7 @@
 </file>
 
 <file path=ppt/slides/slide7.xml><?xml version="1.0" encoding="utf-8"?>
-<p:sld xmlns:a="http://schemas.openxmlformats.org/drawingml/2006/main" xmlns:p="http://schemas.openxmlformats.org/presentationml/2006/main" xmlns:r="http://schemas.openxmlformats.org/officeDocument/2006/relationships">
+<p:sld xmlns:a="http://schemas.openxmlformats.org/drawingml/2006/main" xmlns:r="http://schemas.openxmlformats.org/officeDocument/2006/relationships" xmlns:p="http://schemas.openxmlformats.org/presentationml/2006/main">
   <p:cSld>
     <p:spTree>
       <p:nvGrpSpPr>
@@ -9118,7 +9319,14 @@
         <p:cNvGrpSpPr/>
         <p:nvPr/>
       </p:nvGrpSpPr>
-      <p:grpSpPr/>
+      <p:grpSpPr>
+        <a:xfrm>
+          <a:off x="0" y="0"/>
+          <a:ext cx="0" cy="0"/>
+          <a:chOff x="0" y="0"/>
+          <a:chExt cx="0" cy="0"/>
+        </a:xfrm>
+      </p:grpSpPr>
       <p:sp>
         <p:nvSpPr>
           <p:cNvPr id="2" name="Rectangle 1"/>
@@ -9159,6 +9367,7 @@
           <a:lstStyle/>
           <a:p>
             <a:pPr algn="ctr"/>
+            <a:endParaRPr/>
           </a:p>
         </p:txBody>
       </p:sp>
@@ -9237,6 +9446,7 @@
           <a:lstStyle/>
           <a:p>
             <a:pPr algn="ctr"/>
+            <a:endParaRPr/>
           </a:p>
         </p:txBody>
       </p:sp>
@@ -9388,6 +9598,7 @@
           <a:lstStyle/>
           <a:p>
             <a:pPr algn="ctr"/>
+            <a:endParaRPr/>
           </a:p>
         </p:txBody>
       </p:sp>
@@ -9713,6 +9924,7 @@
           <a:lstStyle/>
           <a:p>
             <a:pPr algn="ctr"/>
+            <a:endParaRPr/>
           </a:p>
         </p:txBody>
       </p:sp>
@@ -10038,6 +10250,7 @@
           <a:lstStyle/>
           <a:p>
             <a:pPr algn="ctr"/>
+            <a:endParaRPr/>
           </a:p>
         </p:txBody>
       </p:sp>
@@ -10330,7 +10543,7 @@
 </file>
 
 <file path=ppt/slides/slide8.xml><?xml version="1.0" encoding="utf-8"?>
-<p:sld xmlns:a="http://schemas.openxmlformats.org/drawingml/2006/main" xmlns:p="http://schemas.openxmlformats.org/presentationml/2006/main" xmlns:r="http://schemas.openxmlformats.org/officeDocument/2006/relationships">
+<p:sld xmlns:a="http://schemas.openxmlformats.org/drawingml/2006/main" xmlns:r="http://schemas.openxmlformats.org/officeDocument/2006/relationships" xmlns:p="http://schemas.openxmlformats.org/presentationml/2006/main">
   <p:cSld>
     <p:spTree>
       <p:nvGrpSpPr>
@@ -10338,7 +10551,14 @@
         <p:cNvGrpSpPr/>
         <p:nvPr/>
       </p:nvGrpSpPr>
-      <p:grpSpPr/>
+      <p:grpSpPr>
+        <a:xfrm>
+          <a:off x="0" y="0"/>
+          <a:ext cx="0" cy="0"/>
+          <a:chOff x="0" y="0"/>
+          <a:chExt cx="0" cy="0"/>
+        </a:xfrm>
+      </p:grpSpPr>
       <p:sp>
         <p:nvSpPr>
           <p:cNvPr id="2" name="Rectangle 1"/>
@@ -10379,6 +10599,7 @@
           <a:lstStyle/>
           <a:p>
             <a:pPr algn="ctr"/>
+            <a:endParaRPr/>
           </a:p>
         </p:txBody>
       </p:sp>
@@ -10457,6 +10678,7 @@
           <a:lstStyle/>
           <a:p>
             <a:pPr algn="ctr"/>
+            <a:endParaRPr/>
           </a:p>
         </p:txBody>
       </p:sp>
@@ -10575,7 +10797,7 @@
         </p:nvGraphicFramePr>
         <p:xfrm>
           <a:off x="457200" y="2606040"/>
-          <a:ext cx="11247120" cy="2304288"/>
+          <a:ext cx="11247120" cy="2346960"/>
         </p:xfrm>
         <a:graphic>
           <a:graphicData uri="http://schemas.openxmlformats.org/drawingml/2006/table">
@@ -10584,17 +10806,53 @@
                 <a:tableStyleId>{5C22544A-7EE6-4342-B048-85BDC9FD1C3A}</a:tableStyleId>
               </a:tblPr>
               <a:tblGrid>
-                <a:gridCol w="2377440"/>
-                <a:gridCol w="1828800"/>
-                <a:gridCol w="1188720"/>
-                <a:gridCol w="1645920"/>
-                <a:gridCol w="1737360"/>
-                <a:gridCol w="2468880"/>
+                <a:gridCol w="2377440">
+                  <a:extLst>
+                    <a:ext uri="{9D8B030D-6E8A-4147-A177-3AD203B41FA5}">
+                      <a16:colId xmlns:a16="http://schemas.microsoft.com/office/drawing/2014/main" val="20000"/>
+                    </a:ext>
+                  </a:extLst>
+                </a:gridCol>
+                <a:gridCol w="1828800">
+                  <a:extLst>
+                    <a:ext uri="{9D8B030D-6E8A-4147-A177-3AD203B41FA5}">
+                      <a16:colId xmlns:a16="http://schemas.microsoft.com/office/drawing/2014/main" val="20001"/>
+                    </a:ext>
+                  </a:extLst>
+                </a:gridCol>
+                <a:gridCol w="1188720">
+                  <a:extLst>
+                    <a:ext uri="{9D8B030D-6E8A-4147-A177-3AD203B41FA5}">
+                      <a16:colId xmlns:a16="http://schemas.microsoft.com/office/drawing/2014/main" val="20002"/>
+                    </a:ext>
+                  </a:extLst>
+                </a:gridCol>
+                <a:gridCol w="1645920">
+                  <a:extLst>
+                    <a:ext uri="{9D8B030D-6E8A-4147-A177-3AD203B41FA5}">
+                      <a16:colId xmlns:a16="http://schemas.microsoft.com/office/drawing/2014/main" val="20003"/>
+                    </a:ext>
+                  </a:extLst>
+                </a:gridCol>
+                <a:gridCol w="1737360">
+                  <a:extLst>
+                    <a:ext uri="{9D8B030D-6E8A-4147-A177-3AD203B41FA5}">
+                      <a16:colId xmlns:a16="http://schemas.microsoft.com/office/drawing/2014/main" val="20004"/>
+                    </a:ext>
+                  </a:extLst>
+                </a:gridCol>
+                <a:gridCol w="2468880">
+                  <a:extLst>
+                    <a:ext uri="{9D8B030D-6E8A-4147-A177-3AD203B41FA5}">
+                      <a16:colId xmlns:a16="http://schemas.microsoft.com/office/drawing/2014/main" val="20005"/>
+                    </a:ext>
+                  </a:extLst>
+                </a:gridCol>
               </a:tblGrid>
               <a:tr h="384048">
                 <a:tc>
                   <a:txBody>
-                    <a:bodyPr wrap="square"/>
+                    <a:bodyPr/>
                     <a:lstStyle/>
                     <a:p>
                       <a:pPr algn="ctr"/>
@@ -10617,7 +10875,7 @@
                 </a:tc>
                 <a:tc>
                   <a:txBody>
-                    <a:bodyPr wrap="square"/>
+                    <a:bodyPr/>
                     <a:lstStyle/>
                     <a:p>
                       <a:pPr algn="ctr"/>
@@ -10640,7 +10898,7 @@
                 </a:tc>
                 <a:tc>
                   <a:txBody>
-                    <a:bodyPr wrap="square"/>
+                    <a:bodyPr/>
                     <a:lstStyle/>
                     <a:p>
                       <a:pPr algn="ctr"/>
@@ -10663,7 +10921,7 @@
                 </a:tc>
                 <a:tc>
                   <a:txBody>
-                    <a:bodyPr wrap="square"/>
+                    <a:bodyPr/>
                     <a:lstStyle/>
                     <a:p>
                       <a:pPr algn="ctr"/>
@@ -10686,7 +10944,7 @@
                 </a:tc>
                 <a:tc>
                   <a:txBody>
-                    <a:bodyPr wrap="square"/>
+                    <a:bodyPr/>
                     <a:lstStyle/>
                     <a:p>
                       <a:pPr algn="ctr"/>
@@ -10709,7 +10967,7 @@
                 </a:tc>
                 <a:tc>
                   <a:txBody>
-                    <a:bodyPr wrap="square"/>
+                    <a:bodyPr/>
                     <a:lstStyle/>
                     <a:p>
                       <a:pPr algn="ctr"/>
@@ -10730,11 +10988,16 @@
                     </a:solidFill>
                   </a:tcPr>
                 </a:tc>
+                <a:extLst>
+                  <a:ext uri="{0D108BD9-81ED-4DB2-BD59-A6C34878D82A}">
+                    <a16:rowId xmlns:a16="http://schemas.microsoft.com/office/drawing/2014/main" val="10000"/>
+                  </a:ext>
+                </a:extLst>
               </a:tr>
               <a:tr h="384048">
                 <a:tc>
                   <a:txBody>
-                    <a:bodyPr wrap="square"/>
+                    <a:bodyPr/>
                     <a:lstStyle/>
                     <a:p>
                       <a:pPr algn="l"/>
@@ -10757,7 +11020,7 @@
                 </a:tc>
                 <a:tc>
                   <a:txBody>
-                    <a:bodyPr wrap="square"/>
+                    <a:bodyPr/>
                     <a:lstStyle/>
                     <a:p>
                       <a:pPr algn="ctr"/>
@@ -10780,7 +11043,7 @@
                 </a:tc>
                 <a:tc>
                   <a:txBody>
-                    <a:bodyPr wrap="square"/>
+                    <a:bodyPr/>
                     <a:lstStyle/>
                     <a:p>
                       <a:pPr algn="ctr"/>
@@ -10803,7 +11066,7 @@
                 </a:tc>
                 <a:tc>
                   <a:txBody>
-                    <a:bodyPr wrap="square"/>
+                    <a:bodyPr/>
                     <a:lstStyle/>
                     <a:p>
                       <a:pPr algn="ctr"/>
@@ -10826,7 +11089,7 @@
                 </a:tc>
                 <a:tc>
                   <a:txBody>
-                    <a:bodyPr wrap="square"/>
+                    <a:bodyPr/>
                     <a:lstStyle/>
                     <a:p>
                       <a:pPr algn="ctr"/>
@@ -10849,7 +11112,7 @@
                 </a:tc>
                 <a:tc>
                   <a:txBody>
-                    <a:bodyPr wrap="square"/>
+                    <a:bodyPr/>
                     <a:lstStyle/>
                     <a:p>
                       <a:pPr algn="ctr"/>
@@ -10870,11 +11133,16 @@
                     </a:solidFill>
                   </a:tcPr>
                 </a:tc>
+                <a:extLst>
+                  <a:ext uri="{0D108BD9-81ED-4DB2-BD59-A6C34878D82A}">
+                    <a16:rowId xmlns:a16="http://schemas.microsoft.com/office/drawing/2014/main" val="10001"/>
+                  </a:ext>
+                </a:extLst>
               </a:tr>
               <a:tr h="384048">
                 <a:tc>
                   <a:txBody>
-                    <a:bodyPr wrap="square"/>
+                    <a:bodyPr/>
                     <a:lstStyle/>
                     <a:p>
                       <a:pPr algn="l"/>
@@ -10897,7 +11165,7 @@
                 </a:tc>
                 <a:tc>
                   <a:txBody>
-                    <a:bodyPr wrap="square"/>
+                    <a:bodyPr/>
                     <a:lstStyle/>
                     <a:p>
                       <a:pPr algn="ctr"/>
@@ -10920,7 +11188,7 @@
                 </a:tc>
                 <a:tc>
                   <a:txBody>
-                    <a:bodyPr wrap="square"/>
+                    <a:bodyPr/>
                     <a:lstStyle/>
                     <a:p>
                       <a:pPr algn="ctr"/>
@@ -10943,7 +11211,7 @@
                 </a:tc>
                 <a:tc>
                   <a:txBody>
-                    <a:bodyPr wrap="square"/>
+                    <a:bodyPr/>
                     <a:lstStyle/>
                     <a:p>
                       <a:pPr algn="ctr"/>
@@ -10966,7 +11234,7 @@
                 </a:tc>
                 <a:tc>
                   <a:txBody>
-                    <a:bodyPr wrap="square"/>
+                    <a:bodyPr/>
                     <a:lstStyle/>
                     <a:p>
                       <a:pPr algn="ctr"/>
@@ -10989,7 +11257,7 @@
                 </a:tc>
                 <a:tc>
                   <a:txBody>
-                    <a:bodyPr wrap="square"/>
+                    <a:bodyPr/>
                     <a:lstStyle/>
                     <a:p>
                       <a:pPr algn="ctr"/>
@@ -11010,11 +11278,16 @@
                     </a:solidFill>
                   </a:tcPr>
                 </a:tc>
+                <a:extLst>
+                  <a:ext uri="{0D108BD9-81ED-4DB2-BD59-A6C34878D82A}">
+                    <a16:rowId xmlns:a16="http://schemas.microsoft.com/office/drawing/2014/main" val="10002"/>
+                  </a:ext>
+                </a:extLst>
               </a:tr>
               <a:tr h="384048">
                 <a:tc>
                   <a:txBody>
-                    <a:bodyPr wrap="square"/>
+                    <a:bodyPr/>
                     <a:lstStyle/>
                     <a:p>
                       <a:pPr algn="l"/>
@@ -11037,7 +11310,7 @@
                 </a:tc>
                 <a:tc>
                   <a:txBody>
-                    <a:bodyPr wrap="square"/>
+                    <a:bodyPr/>
                     <a:lstStyle/>
                     <a:p>
                       <a:pPr algn="ctr"/>
@@ -11060,7 +11333,7 @@
                 </a:tc>
                 <a:tc>
                   <a:txBody>
-                    <a:bodyPr wrap="square"/>
+                    <a:bodyPr/>
                     <a:lstStyle/>
                     <a:p>
                       <a:pPr algn="ctr"/>
@@ -11083,7 +11356,7 @@
                 </a:tc>
                 <a:tc>
                   <a:txBody>
-                    <a:bodyPr wrap="square"/>
+                    <a:bodyPr/>
                     <a:lstStyle/>
                     <a:p>
                       <a:pPr algn="ctr"/>
@@ -11106,7 +11379,7 @@
                 </a:tc>
                 <a:tc>
                   <a:txBody>
-                    <a:bodyPr wrap="square"/>
+                    <a:bodyPr/>
                     <a:lstStyle/>
                     <a:p>
                       <a:pPr algn="ctr"/>
@@ -11129,7 +11402,7 @@
                 </a:tc>
                 <a:tc>
                   <a:txBody>
-                    <a:bodyPr wrap="square"/>
+                    <a:bodyPr/>
                     <a:lstStyle/>
                     <a:p>
                       <a:pPr algn="ctr"/>
@@ -11150,11 +11423,16 @@
                     </a:solidFill>
                   </a:tcPr>
                 </a:tc>
+                <a:extLst>
+                  <a:ext uri="{0D108BD9-81ED-4DB2-BD59-A6C34878D82A}">
+                    <a16:rowId xmlns:a16="http://schemas.microsoft.com/office/drawing/2014/main" val="10003"/>
+                  </a:ext>
+                </a:extLst>
               </a:tr>
               <a:tr h="384048">
                 <a:tc>
                   <a:txBody>
-                    <a:bodyPr wrap="square"/>
+                    <a:bodyPr/>
                     <a:lstStyle/>
                     <a:p>
                       <a:pPr algn="l"/>
@@ -11177,7 +11455,7 @@
                 </a:tc>
                 <a:tc>
                   <a:txBody>
-                    <a:bodyPr wrap="square"/>
+                    <a:bodyPr/>
                     <a:lstStyle/>
                     <a:p>
                       <a:pPr algn="ctr"/>
@@ -11200,7 +11478,7 @@
                 </a:tc>
                 <a:tc>
                   <a:txBody>
-                    <a:bodyPr wrap="square"/>
+                    <a:bodyPr/>
                     <a:lstStyle/>
                     <a:p>
                       <a:pPr algn="ctr"/>
@@ -11223,7 +11501,7 @@
                 </a:tc>
                 <a:tc>
                   <a:txBody>
-                    <a:bodyPr wrap="square"/>
+                    <a:bodyPr/>
                     <a:lstStyle/>
                     <a:p>
                       <a:pPr algn="ctr"/>
@@ -11246,7 +11524,7 @@
                 </a:tc>
                 <a:tc>
                   <a:txBody>
-                    <a:bodyPr wrap="square"/>
+                    <a:bodyPr/>
                     <a:lstStyle/>
                     <a:p>
                       <a:pPr algn="ctr"/>
@@ -11269,7 +11547,7 @@
                 </a:tc>
                 <a:tc>
                   <a:txBody>
-                    <a:bodyPr wrap="square"/>
+                    <a:bodyPr/>
                     <a:lstStyle/>
                     <a:p>
                       <a:pPr algn="ctr"/>
@@ -11290,11 +11568,16 @@
                     </a:solidFill>
                   </a:tcPr>
                 </a:tc>
+                <a:extLst>
+                  <a:ext uri="{0D108BD9-81ED-4DB2-BD59-A6C34878D82A}">
+                    <a16:rowId xmlns:a16="http://schemas.microsoft.com/office/drawing/2014/main" val="10004"/>
+                  </a:ext>
+                </a:extLst>
               </a:tr>
               <a:tr h="384048">
                 <a:tc>
                   <a:txBody>
-                    <a:bodyPr wrap="square"/>
+                    <a:bodyPr/>
                     <a:lstStyle/>
                     <a:p>
                       <a:pPr algn="l"/>
@@ -11317,7 +11600,7 @@
                 </a:tc>
                 <a:tc>
                   <a:txBody>
-                    <a:bodyPr wrap="square"/>
+                    <a:bodyPr/>
                     <a:lstStyle/>
                     <a:p>
                       <a:pPr algn="ctr"/>
@@ -11340,7 +11623,7 @@
                 </a:tc>
                 <a:tc>
                   <a:txBody>
-                    <a:bodyPr wrap="square"/>
+                    <a:bodyPr/>
                     <a:lstStyle/>
                     <a:p>
                       <a:pPr algn="ctr"/>
@@ -11363,7 +11646,7 @@
                 </a:tc>
                 <a:tc>
                   <a:txBody>
-                    <a:bodyPr wrap="square"/>
+                    <a:bodyPr/>
                     <a:lstStyle/>
                     <a:p>
                       <a:pPr algn="ctr"/>
@@ -11386,7 +11669,7 @@
                 </a:tc>
                 <a:tc>
                   <a:txBody>
-                    <a:bodyPr wrap="square"/>
+                    <a:bodyPr/>
                     <a:lstStyle/>
                     <a:p>
                       <a:pPr algn="ctr"/>
@@ -11409,7 +11692,7 @@
                 </a:tc>
                 <a:tc>
                   <a:txBody>
-                    <a:bodyPr wrap="square"/>
+                    <a:bodyPr/>
                     <a:lstStyle/>
                     <a:p>
                       <a:pPr algn="ctr"/>
@@ -11430,6 +11713,11 @@
                     </a:solidFill>
                   </a:tcPr>
                 </a:tc>
+                <a:extLst>
+                  <a:ext uri="{0D108BD9-81ED-4DB2-BD59-A6C34878D82A}">
+                    <a16:rowId xmlns:a16="http://schemas.microsoft.com/office/drawing/2014/main" val="10005"/>
+                  </a:ext>
+                </a:extLst>
               </a:tr>
             </a:tbl>
           </a:graphicData>
@@ -11444,7 +11732,7 @@
 </file>
 
 <file path=ppt/slides/slide9.xml><?xml version="1.0" encoding="utf-8"?>
-<p:sld xmlns:a="http://schemas.openxmlformats.org/drawingml/2006/main" xmlns:p="http://schemas.openxmlformats.org/presentationml/2006/main" xmlns:r="http://schemas.openxmlformats.org/officeDocument/2006/relationships">
+<p:sld xmlns:a="http://schemas.openxmlformats.org/drawingml/2006/main" xmlns:r="http://schemas.openxmlformats.org/officeDocument/2006/relationships" xmlns:p="http://schemas.openxmlformats.org/presentationml/2006/main">
   <p:cSld>
     <p:spTree>
       <p:nvGrpSpPr>
@@ -11452,7 +11740,14 @@
         <p:cNvGrpSpPr/>
         <p:nvPr/>
       </p:nvGrpSpPr>
-      <p:grpSpPr/>
+      <p:grpSpPr>
+        <a:xfrm>
+          <a:off x="0" y="0"/>
+          <a:ext cx="0" cy="0"/>
+          <a:chOff x="0" y="0"/>
+          <a:chExt cx="0" cy="0"/>
+        </a:xfrm>
+      </p:grpSpPr>
       <p:sp>
         <p:nvSpPr>
           <p:cNvPr id="2" name="Rectangle 1"/>
@@ -11493,6 +11788,7 @@
           <a:lstStyle/>
           <a:p>
             <a:pPr algn="ctr"/>
+            <a:endParaRPr/>
           </a:p>
         </p:txBody>
       </p:sp>
@@ -11571,6 +11867,7 @@
           <a:lstStyle/>
           <a:p>
             <a:pPr algn="ctr"/>
+            <a:endParaRPr/>
           </a:p>
         </p:txBody>
       </p:sp>
@@ -11721,6 +12018,7 @@
           <a:lstStyle/>
           <a:p>
             <a:pPr algn="ctr"/>
+            <a:endParaRPr/>
           </a:p>
         </p:txBody>
       </p:sp>
@@ -11801,6 +12099,7 @@
           <a:lstStyle/>
           <a:p>
             <a:pPr algn="ctr"/>
+            <a:endParaRPr/>
           </a:p>
         </p:txBody>
       </p:sp>
@@ -11881,6 +12180,7 @@
           <a:lstStyle/>
           <a:p>
             <a:pPr algn="ctr"/>
+            <a:endParaRPr/>
           </a:p>
         </p:txBody>
       </p:sp>
@@ -11961,6 +12261,7 @@
           <a:lstStyle/>
           <a:p>
             <a:pPr algn="ctr"/>
+            <a:endParaRPr/>
           </a:p>
         </p:txBody>
       </p:sp>
@@ -12041,6 +12342,7 @@
           <a:lstStyle/>
           <a:p>
             <a:pPr algn="ctr"/>
+            <a:endParaRPr/>
           </a:p>
         </p:txBody>
       </p:sp>
@@ -12121,6 +12423,7 @@
           <a:lstStyle/>
           <a:p>
             <a:pPr algn="ctr"/>
+            <a:endParaRPr/>
           </a:p>
         </p:txBody>
       </p:sp>
@@ -12201,6 +12504,7 @@
           <a:lstStyle/>
           <a:p>
             <a:pPr algn="ctr"/>
+            <a:endParaRPr/>
           </a:p>
         </p:txBody>
       </p:sp>
@@ -12281,6 +12585,7 @@
           <a:lstStyle/>
           <a:p>
             <a:pPr algn="ctr"/>
+            <a:endParaRPr/>
           </a:p>
         </p:txBody>
       </p:sp>
@@ -12361,6 +12666,7 @@
           <a:lstStyle/>
           <a:p>
             <a:pPr algn="ctr"/>
+            <a:endParaRPr/>
           </a:p>
         </p:txBody>
       </p:sp>
@@ -12441,6 +12747,7 @@
           <a:lstStyle/>
           <a:p>
             <a:pPr algn="ctr"/>
+            <a:endParaRPr/>
           </a:p>
         </p:txBody>
       </p:sp>
@@ -12521,6 +12828,7 @@
           <a:lstStyle/>
           <a:p>
             <a:pPr algn="ctr"/>
+            <a:endParaRPr/>
           </a:p>
         </p:txBody>
       </p:sp>
@@ -12601,6 +12909,7 @@
           <a:lstStyle/>
           <a:p>
             <a:pPr algn="ctr"/>
+            <a:endParaRPr/>
           </a:p>
         </p:txBody>
       </p:sp>
@@ -12681,6 +12990,7 @@
           <a:lstStyle/>
           <a:p>
             <a:pPr algn="ctr"/>
+            <a:endParaRPr/>
           </a:p>
         </p:txBody>
       </p:sp>
@@ -12761,6 +13071,7 @@
           <a:lstStyle/>
           <a:p>
             <a:pPr algn="ctr"/>
+            <a:endParaRPr/>
           </a:p>
         </p:txBody>
       </p:sp>
@@ -12841,6 +13152,7 @@
           <a:lstStyle/>
           <a:p>
             <a:pPr algn="ctr"/>
+            <a:endParaRPr/>
           </a:p>
         </p:txBody>
       </p:sp>
@@ -12921,6 +13233,7 @@
           <a:lstStyle/>
           <a:p>
             <a:pPr algn="ctr"/>
+            <a:endParaRPr/>
           </a:p>
         </p:txBody>
       </p:sp>

</xml_diff>